<commit_message>
Update approved FCS manuscript and saved sensitivity artifacts
</commit_message>
<xml_diff>
--- a/paper/fcs/highlights_fcs.pptx
+++ b/paper/fcs/highlights_fcs.pptx
@@ -2,15 +2,15 @@
 <file path=ppt/presentation.xml><?xml version="1.0" encoding="utf-8"?>
 <p:presentation xmlns:p="http://schemas.openxmlformats.org/presentationml/2006/main">
   <p:sldMasterIdLst>
-    <p:sldMasterId xmlns:r="http://schemas.openxmlformats.org/officeDocument/2006/relationships" id="2147483648" r:id="R19e1bcbd99c24a2f"/>
+    <p:sldMasterId xmlns:r="http://schemas.openxmlformats.org/officeDocument/2006/relationships" id="2147483648" r:id="R0420dcc294bb460c"/>
   </p:sldMasterIdLst>
   <p:notesMasterIdLst>
-    <p:notesMasterId xmlns:r="http://schemas.openxmlformats.org/officeDocument/2006/relationships" r:id="R3e51a9c421d04c2f"/>
+    <p:notesMasterId xmlns:r="http://schemas.openxmlformats.org/officeDocument/2006/relationships" r:id="R4d4bab2fe58f4f45"/>
   </p:notesMasterIdLst>
   <p:sldIdLst>
-    <p:sldId xmlns:r="http://schemas.openxmlformats.org/officeDocument/2006/relationships" id="256" r:id="R97efab627c35477c"/>
-    <p:sldId xmlns:r="http://schemas.openxmlformats.org/officeDocument/2006/relationships" id="257" r:id="R582d36ec634f4287"/>
-    <p:sldId xmlns:r="http://schemas.openxmlformats.org/officeDocument/2006/relationships" id="258" r:id="R053660a1519c4201"/>
+    <p:sldId xmlns:r="http://schemas.openxmlformats.org/officeDocument/2006/relationships" id="256" r:id="R207cd337ffe94ce6"/>
+    <p:sldId xmlns:r="http://schemas.openxmlformats.org/officeDocument/2006/relationships" id="257" r:id="Rb65f8ce603fc4760"/>
+    <p:sldId xmlns:r="http://schemas.openxmlformats.org/officeDocument/2006/relationships" id="258" r:id="R87b2a462989248a4"/>
   </p:sldIdLst>
   <p:sldSz cx="12192000" cy="6858000"/>
   <p:notesSz cx="6858000" cy="9144000"/>
@@ -444,7 +444,7 @@
           <a:lstStyle xmlns:a="http://schemas.openxmlformats.org/drawingml/2006/main"/>
           <a:p xmlns:a="http://schemas.openxmlformats.org/drawingml/2006/main">
             <a:r>
-              <a:t>Source: current manuscript, Model and main results; Fig. 2 (model_scales). Integer capacity satisfies 2c/q → κ &gt; 0. The figure is reproduced unchanged from the manuscript. Full title: Critical Overflow in Weakly Coupled Two-Choice Allocation.</a:t>
+              <a:t>Source: main article, Introduction and Model and main results; Fig. 2 (model_scales). The model starts empty with two communities of q buckets, uniform complete-bipartite internal candidates, predetermined doubly stochastic cross kernels, and left-favored ties. The scaling is epsilon*q to lambda and 2*c_q/q to kappa. Corollary 2.4 identifies the positive leading internal contribution.</a:t>
             </a:r>
           </a:p>
         </p:txBody>
@@ -514,7 +514,7 @@
           <a:lstStyle xmlns:a="http://schemas.openxmlformats.org/drawingml/2006/main"/>
           <a:p xmlns:a="http://schemas.openxmlformats.org/drawingml/2006/main">
             <a:r>
-              <a:t>Source: current manuscript, Corollary 2.4, certified evaluation, and Fig. 1 (readout_teaser). For every finite d, S_0(d) &gt; |d|/2. The displayed finite-size comparison uses 4096 saved endpoints at q=512, κ=1, λ=1 with matching crosses. Both readouts use the same observed imbalance. This compares prediction errors, not allocation algorithms.</a:t>
+              <a:t>Source: main article, Theorems 2.1-2.3, Corollaries 2.4-2.5, Numerical evaluation, and Fig. 1 (readout_teaser). The coefficient 0.6313 is the phase-zero, zero-imbalance limiting readout S_0(0). The figure uses 4096 saved endpoints at q=512, kappa=lambda=1 with matching crosses. It compares the profile and community-excess readouts at the same observed imbalance.</a:t>
             </a:r>
           </a:p>
         </p:txBody>
@@ -584,7 +584,7 @@
           <a:lstStyle xmlns:a="http://schemas.openxmlformats.org/drawingml/2006/main"/>
           <a:p xmlns:a="http://schemas.openxmlformats.org/drawingml/2006/main">
             <a:r>
-              <a:t>Source: current manuscript, Theorems 2.1–2.3, Corollary 2.5, and Fig. 4 (kernel_universality). The theorem assumes εq → λ &lt; ∞, integer capacity 2c/q → κ &gt; 0, empty starts, complete-bipartite internal sampling, and left-favored ties. Kernels are predetermined and doubly stochastic. The conclusion does not cover adaptive kernels. Figure reproduced unchanged.</a:t>
+              <a:t>Source: main article, Section 6.5, Table 2, Fig. 5 (topology_amplification), and Section 7.3. The ratios compare unconditional sample means of G_c/q, with G_c=Z_c-|Delta|/2 at critical fill. For q=512, kappa=lambda=1 and left ties, the complete-bipartite, cycle, and matching means are 0.3958110809326172, 2.3062000274658203, and 8.463871002197266. The displayed ratios round 5.826517090 and 21.383613067. Error bars in the source figure show twice Monte Carlo standard error conditional on the fixed graphs. The monitoring statement follows from the aggregation identity G_c=sum_s min(E_s,U_s).</a:t>
             </a:r>
           </a:p>
         </p:txBody>
@@ -3027,12 +3027,12 @@
   </p:cSld>
   <p:clrMap bg1="lt1" tx1="dk1" bg2="lt2" tx2="dk2" accent1="accent1" accent2="accent2" accent3="accent3" accent4="accent4" accent5="accent5" accent6="accent6" hlink="hlink" folHlink="folHlink"/>
   <p:sldLayoutIdLst>
-    <p:sldLayoutId xmlns:r="http://schemas.openxmlformats.org/officeDocument/2006/relationships" id="2147483649" r:id="R8720e4f230f64357"/>
-    <p:sldLayoutId xmlns:r="http://schemas.openxmlformats.org/officeDocument/2006/relationships" id="2147483650" r:id="R7b376f6ba15f43bb"/>
-    <p:sldLayoutId xmlns:r="http://schemas.openxmlformats.org/officeDocument/2006/relationships" id="2147483651" r:id="R15f6118837674532"/>
-    <p:sldLayoutId xmlns:r="http://schemas.openxmlformats.org/officeDocument/2006/relationships" id="2147483652" r:id="R78294596a6a244c0"/>
-    <p:sldLayoutId xmlns:r="http://schemas.openxmlformats.org/officeDocument/2006/relationships" id="2147483653" r:id="R2f28ad4b5f84424e"/>
-    <p:sldLayoutId xmlns:r="http://schemas.openxmlformats.org/officeDocument/2006/relationships" id="2147483654" r:id="R03e62a7dcc194d64"/>
+    <p:sldLayoutId xmlns:r="http://schemas.openxmlformats.org/officeDocument/2006/relationships" id="2147483649" r:id="Raf1b1e101f994311"/>
+    <p:sldLayoutId xmlns:r="http://schemas.openxmlformats.org/officeDocument/2006/relationships" id="2147483650" r:id="Ra66c407a95f54777"/>
+    <p:sldLayoutId xmlns:r="http://schemas.openxmlformats.org/officeDocument/2006/relationships" id="2147483651" r:id="R0f391346a3d8465c"/>
+    <p:sldLayoutId xmlns:r="http://schemas.openxmlformats.org/officeDocument/2006/relationships" id="2147483652" r:id="R15922107c0bc4d93"/>
+    <p:sldLayoutId xmlns:r="http://schemas.openxmlformats.org/officeDocument/2006/relationships" id="2147483653" r:id="R54362bc30d4449d5"/>
+    <p:sldLayoutId xmlns:r="http://schemas.openxmlformats.org/officeDocument/2006/relationships" id="2147483654" r:id="R8d6382425ec9469c"/>
   </p:sldLayoutIdLst>
   <p:txStyles>
     <p:titleStyle>
@@ -3608,7 +3608,7 @@
         <p:txBody>
           <a:bodyPr xmlns:a="http://schemas.openxmlformats.org/drawingml/2006/main"/>
           <a:lstStyle xmlns:a="http://schemas.openxmlformats.org/drawingml/2006/main">
-            <a:defPPr>
+            <a:defPPr algn="l">
               <a:defRPr sz="3150" b="1">
                 <a:solidFill>
                   <a:srgbClr val="183153"/>
@@ -3618,7 +3618,8 @@
                 <a:cs typeface="Arial"/>
               </a:defRPr>
             </a:defPPr>
-            <a:lvl1pPr>
+            <a:lvl1pPr algn="l">
+              <a:buNone/>
               <a:defRPr sz="3150" b="1">
                 <a:solidFill>
                   <a:srgbClr val="183153"/>
@@ -3628,7 +3629,8 @@
                 <a:cs typeface="Arial"/>
               </a:defRPr>
             </a:lvl1pPr>
-            <a:lvl2pPr>
+            <a:lvl2pPr algn="l">
+              <a:buNone/>
               <a:defRPr sz="3150" b="1">
                 <a:solidFill>
                   <a:srgbClr val="183153"/>
@@ -3638,7 +3640,8 @@
                 <a:cs typeface="Arial"/>
               </a:defRPr>
             </a:lvl2pPr>
-            <a:lvl3pPr>
+            <a:lvl3pPr algn="l">
+              <a:buNone/>
               <a:defRPr sz="3150" b="1">
                 <a:solidFill>
                   <a:srgbClr val="183153"/>
@@ -3648,7 +3651,8 @@
                 <a:cs typeface="Arial"/>
               </a:defRPr>
             </a:lvl3pPr>
-            <a:lvl4pPr>
+            <a:lvl4pPr algn="l">
+              <a:buNone/>
               <a:defRPr sz="3150" b="1">
                 <a:solidFill>
                   <a:srgbClr val="183153"/>
@@ -3658,7 +3662,8 @@
                 <a:cs typeface="Arial"/>
               </a:defRPr>
             </a:lvl4pPr>
-            <a:lvl5pPr>
+            <a:lvl5pPr algn="l">
+              <a:buNone/>
               <a:defRPr sz="3150" b="1">
                 <a:solidFill>
                   <a:srgbClr val="183153"/>
@@ -3668,7 +3673,8 @@
                 <a:cs typeface="Arial"/>
               </a:defRPr>
             </a:lvl5pPr>
-            <a:lvl6pPr>
+            <a:lvl6pPr algn="l">
+              <a:buNone/>
               <a:defRPr sz="3150" b="1">
                 <a:solidFill>
                   <a:srgbClr val="183153"/>
@@ -3678,7 +3684,8 @@
                 <a:cs typeface="Arial"/>
               </a:defRPr>
             </a:lvl6pPr>
-            <a:lvl7pPr>
+            <a:lvl7pPr algn="l">
+              <a:buNone/>
               <a:defRPr sz="3150" b="1">
                 <a:solidFill>
                   <a:srgbClr val="183153"/>
@@ -3688,7 +3695,8 @@
                 <a:cs typeface="Arial"/>
               </a:defRPr>
             </a:lvl7pPr>
-            <a:lvl8pPr>
+            <a:lvl8pPr algn="l">
+              <a:buNone/>
               <a:defRPr sz="3150" b="1">
                 <a:solidFill>
                   <a:srgbClr val="183153"/>
@@ -3698,7 +3706,8 @@
                 <a:cs typeface="Arial"/>
               </a:defRPr>
             </a:lvl8pPr>
-            <a:lvl9pPr>
+            <a:lvl9pPr algn="l">
+              <a:buNone/>
               <a:defRPr sz="3150" b="1">
                 <a:solidFill>
                   <a:srgbClr val="183153"/>
@@ -3710,7 +3719,8 @@
             </a:lvl9pPr>
           </a:lstStyle>
           <a:p xmlns:a="http://schemas.openxmlformats.org/drawingml/2006/main">
-            <a:pPr>
+            <a:pPr algn="l">
+              <a:buNone/>
               <a:defRPr sz="3150" b="1">
                 <a:solidFill>
                   <a:srgbClr val="183153"/>
@@ -3729,7 +3739,7 @@
                 <a:ea typeface="Arial"/>
                 <a:cs typeface="Arial"/>
               </a:rPr>
-              <a:t>Critical overflow in two-choice allocation</a:t>
+              <a:t>Capacity loss hidden by community totals</a:t>
             </a:r>
           </a:p>
         </p:txBody>
@@ -3775,6 +3785,7 @@
               </a:defRPr>
             </a:defPPr>
             <a:lvl1pPr>
+              <a:buNone/>
               <a:defRPr sz="1725" b="0">
                 <a:solidFill>
                   <a:srgbClr val="526071"/>
@@ -3785,6 +3796,7 @@
               </a:defRPr>
             </a:lvl1pPr>
             <a:lvl2pPr>
+              <a:buNone/>
               <a:defRPr sz="1725" b="0">
                 <a:solidFill>
                   <a:srgbClr val="526071"/>
@@ -3795,6 +3807,7 @@
               </a:defRPr>
             </a:lvl2pPr>
             <a:lvl3pPr>
+              <a:buNone/>
               <a:defRPr sz="1725" b="0">
                 <a:solidFill>
                   <a:srgbClr val="526071"/>
@@ -3805,6 +3818,7 @@
               </a:defRPr>
             </a:lvl3pPr>
             <a:lvl4pPr>
+              <a:buNone/>
               <a:defRPr sz="1725" b="0">
                 <a:solidFill>
                   <a:srgbClr val="526071"/>
@@ -3815,6 +3829,7 @@
               </a:defRPr>
             </a:lvl4pPr>
             <a:lvl5pPr>
+              <a:buNone/>
               <a:defRPr sz="1725" b="0">
                 <a:solidFill>
                   <a:srgbClr val="526071"/>
@@ -3825,6 +3840,7 @@
               </a:defRPr>
             </a:lvl5pPr>
             <a:lvl6pPr>
+              <a:buNone/>
               <a:defRPr sz="1725" b="0">
                 <a:solidFill>
                   <a:srgbClr val="526071"/>
@@ -3835,6 +3851,7 @@
               </a:defRPr>
             </a:lvl6pPr>
             <a:lvl7pPr>
+              <a:buNone/>
               <a:defRPr sz="1725" b="0">
                 <a:solidFill>
                   <a:srgbClr val="526071"/>
@@ -3845,6 +3862,7 @@
               </a:defRPr>
             </a:lvl7pPr>
             <a:lvl8pPr>
+              <a:buNone/>
               <a:defRPr sz="1725" b="0">
                 <a:solidFill>
                   <a:srgbClr val="526071"/>
@@ -3855,6 +3873,7 @@
               </a:defRPr>
             </a:lvl8pPr>
             <a:lvl9pPr>
+              <a:buNone/>
               <a:defRPr sz="1725" b="0">
                 <a:solidFill>
                   <a:srgbClr val="526071"/>
@@ -3867,6 +3886,7 @@
           </a:lstStyle>
           <a:p xmlns:a="http://schemas.openxmlformats.org/drawingml/2006/main">
             <a:pPr>
+              <a:buNone/>
               <a:defRPr sz="1725" b="0">
                 <a:solidFill>
                   <a:srgbClr val="526071"/>
@@ -3920,7 +3940,7 @@
         <p:txBody>
           <a:bodyPr xmlns:a="http://schemas.openxmlformats.org/drawingml/2006/main"/>
           <a:lstStyle xmlns:a="http://schemas.openxmlformats.org/drawingml/2006/main">
-            <a:defPPr>
+            <a:defPPr algn="l">
               <a:defRPr sz="2250" b="0">
                 <a:solidFill>
                   <a:srgbClr val="183153"/>
@@ -3930,7 +3950,8 @@
                 <a:cs typeface="Arial"/>
               </a:defRPr>
             </a:defPPr>
-            <a:lvl1pPr>
+            <a:lvl1pPr algn="l">
+              <a:buNone/>
               <a:defRPr sz="2250" b="0">
                 <a:solidFill>
                   <a:srgbClr val="183153"/>
@@ -3940,7 +3961,8 @@
                 <a:cs typeface="Arial"/>
               </a:defRPr>
             </a:lvl1pPr>
-            <a:lvl2pPr>
+            <a:lvl2pPr algn="l">
+              <a:buNone/>
               <a:defRPr sz="2250" b="0">
                 <a:solidFill>
                   <a:srgbClr val="183153"/>
@@ -3950,7 +3972,8 @@
                 <a:cs typeface="Arial"/>
               </a:defRPr>
             </a:lvl2pPr>
-            <a:lvl3pPr>
+            <a:lvl3pPr algn="l">
+              <a:buNone/>
               <a:defRPr sz="2250" b="0">
                 <a:solidFill>
                   <a:srgbClr val="183153"/>
@@ -3960,7 +3983,8 @@
                 <a:cs typeface="Arial"/>
               </a:defRPr>
             </a:lvl3pPr>
-            <a:lvl4pPr>
+            <a:lvl4pPr algn="l">
+              <a:buNone/>
               <a:defRPr sz="2250" b="0">
                 <a:solidFill>
                   <a:srgbClr val="183153"/>
@@ -3970,7 +3994,8 @@
                 <a:cs typeface="Arial"/>
               </a:defRPr>
             </a:lvl4pPr>
-            <a:lvl5pPr>
+            <a:lvl5pPr algn="l">
+              <a:buNone/>
               <a:defRPr sz="2250" b="0">
                 <a:solidFill>
                   <a:srgbClr val="183153"/>
@@ -3980,7 +4005,8 @@
                 <a:cs typeface="Arial"/>
               </a:defRPr>
             </a:lvl5pPr>
-            <a:lvl6pPr>
+            <a:lvl6pPr algn="l">
+              <a:buNone/>
               <a:defRPr sz="2250" b="0">
                 <a:solidFill>
                   <a:srgbClr val="183153"/>
@@ -3990,7 +4016,8 @@
                 <a:cs typeface="Arial"/>
               </a:defRPr>
             </a:lvl6pPr>
-            <a:lvl7pPr>
+            <a:lvl7pPr algn="l">
+              <a:buNone/>
               <a:defRPr sz="2250" b="0">
                 <a:solidFill>
                   <a:srgbClr val="183153"/>
@@ -4000,7 +4027,8 @@
                 <a:cs typeface="Arial"/>
               </a:defRPr>
             </a:lvl7pPr>
-            <a:lvl8pPr>
+            <a:lvl8pPr algn="l">
+              <a:buNone/>
               <a:defRPr sz="2250" b="0">
                 <a:solidFill>
                   <a:srgbClr val="183153"/>
@@ -4010,7 +4038,8 @@
                 <a:cs typeface="Arial"/>
               </a:defRPr>
             </a:lvl8pPr>
-            <a:lvl9pPr>
+            <a:lvl9pPr algn="l">
+              <a:buNone/>
               <a:defRPr sz="2250" b="0">
                 <a:solidFill>
                   <a:srgbClr val="183153"/>
@@ -4022,7 +4051,8 @@
             </a:lvl9pPr>
           </a:lstStyle>
           <a:p xmlns:a="http://schemas.openxmlformats.org/drawingml/2006/main">
-            <a:pPr>
+            <a:pPr algn="l">
+              <a:buNone/>
               <a:defRPr sz="2250" b="0">
                 <a:solidFill>
                   <a:srgbClr val="183153"/>
@@ -4041,7 +4071,7 @@
                 <a:ea typeface="Arial"/>
                 <a:cs typeface="Arial"/>
               </a:rPr>
-              <a:t>How many items exceed bucket capacity as two weakly coupled communities fill?</a:t>
+              <a:t>Two-choice allocation can leave overloaded buckets beside unused capacity.</a:t>
             </a:r>
           </a:p>
         </p:txBody>
@@ -4051,7 +4081,7 @@
           <p:cNvPr id="4" name="">
             <a:extLst xmlns:a="http://schemas.openxmlformats.org/drawingml/2006/main">
               <a:ext uri="{FF2B5EF4-FFF2-40B4-BE49-F238E27FC236}">
-                <a16:creationId xmlns:a16="http://schemas.microsoft.com/office/drawing/2014/main" id="{92015128-9943-4776-AB36-8D65E0D92A10}"/>
+                <a16:creationId xmlns:a16="http://schemas.microsoft.com/office/drawing/2014/main" id="{89AEC8AA-96AE-4704-8B73-969601ACB272}"/>
               </a:ext>
             </a:extLst>
           </p:cNvPr>
@@ -4061,7 +4091,7 @@
           <p:nvPr/>
         </p:nvPicPr>
         <p:blipFill>
-          <a:blip xmlns:r="http://schemas.openxmlformats.org/officeDocument/2006/relationships" xmlns:a="http://schemas.openxmlformats.org/drawingml/2006/main" r:embed="R2594b9e191d54d12"/>
+          <a:blip xmlns:r="http://schemas.openxmlformats.org/officeDocument/2006/relationships" xmlns:a="http://schemas.openxmlformats.org/drawingml/2006/main" r:embed="R049db323af064bbb"/>
           <a:stretch xmlns:a="http://schemas.openxmlformats.org/drawingml/2006/main"/>
         </p:blipFill>
         <p:spPr>
@@ -4104,7 +4134,7 @@
         <p:txBody>
           <a:bodyPr xmlns:a="http://schemas.openxmlformats.org/drawingml/2006/main"/>
           <a:lstStyle xmlns:a="http://schemas.openxmlformats.org/drawingml/2006/main">
-            <a:defPPr>
+            <a:defPPr algn="l">
               <a:defRPr sz="1875" b="0">
                 <a:solidFill>
                   <a:srgbClr val="183153"/>
@@ -4114,7 +4144,8 @@
                 <a:cs typeface="Arial"/>
               </a:defRPr>
             </a:defPPr>
-            <a:lvl1pPr>
+            <a:lvl1pPr algn="l">
+              <a:buNone/>
               <a:defRPr sz="1875" b="0">
                 <a:solidFill>
                   <a:srgbClr val="183153"/>
@@ -4124,7 +4155,8 @@
                 <a:cs typeface="Arial"/>
               </a:defRPr>
             </a:lvl1pPr>
-            <a:lvl2pPr>
+            <a:lvl2pPr algn="l">
+              <a:buNone/>
               <a:defRPr sz="1875" b="0">
                 <a:solidFill>
                   <a:srgbClr val="183153"/>
@@ -4134,7 +4166,8 @@
                 <a:cs typeface="Arial"/>
               </a:defRPr>
             </a:lvl2pPr>
-            <a:lvl3pPr>
+            <a:lvl3pPr algn="l">
+              <a:buNone/>
               <a:defRPr sz="1875" b="0">
                 <a:solidFill>
                   <a:srgbClr val="183153"/>
@@ -4144,7 +4177,8 @@
                 <a:cs typeface="Arial"/>
               </a:defRPr>
             </a:lvl3pPr>
-            <a:lvl4pPr>
+            <a:lvl4pPr algn="l">
+              <a:buNone/>
               <a:defRPr sz="1875" b="0">
                 <a:solidFill>
                   <a:srgbClr val="183153"/>
@@ -4154,7 +4188,8 @@
                 <a:cs typeface="Arial"/>
               </a:defRPr>
             </a:lvl4pPr>
-            <a:lvl5pPr>
+            <a:lvl5pPr algn="l">
+              <a:buNone/>
               <a:defRPr sz="1875" b="0">
                 <a:solidFill>
                   <a:srgbClr val="183153"/>
@@ -4164,7 +4199,8 @@
                 <a:cs typeface="Arial"/>
               </a:defRPr>
             </a:lvl5pPr>
-            <a:lvl6pPr>
+            <a:lvl6pPr algn="l">
+              <a:buNone/>
               <a:defRPr sz="1875" b="0">
                 <a:solidFill>
                   <a:srgbClr val="183153"/>
@@ -4174,7 +4210,8 @@
                 <a:cs typeface="Arial"/>
               </a:defRPr>
             </a:lvl6pPr>
-            <a:lvl7pPr>
+            <a:lvl7pPr algn="l">
+              <a:buNone/>
               <a:defRPr sz="1875" b="0">
                 <a:solidFill>
                   <a:srgbClr val="183153"/>
@@ -4184,7 +4221,8 @@
                 <a:cs typeface="Arial"/>
               </a:defRPr>
             </a:lvl7pPr>
-            <a:lvl8pPr>
+            <a:lvl8pPr algn="l">
+              <a:buNone/>
               <a:defRPr sz="1875" b="0">
                 <a:solidFill>
                   <a:srgbClr val="183153"/>
@@ -4194,7 +4232,8 @@
                 <a:cs typeface="Arial"/>
               </a:defRPr>
             </a:lvl8pPr>
-            <a:lvl9pPr>
+            <a:lvl9pPr algn="l">
+              <a:buNone/>
               <a:defRPr sz="1875" b="0">
                 <a:solidFill>
                   <a:srgbClr val="183153"/>
@@ -4206,7 +4245,8 @@
             </a:lvl9pPr>
           </a:lstStyle>
           <a:p xmlns:a="http://schemas.openxmlformats.org/drawingml/2006/main">
-            <a:pPr>
+            <a:pPr algn="l">
+              <a:buNone/>
               <a:defRPr sz="1875" b="0">
                 <a:solidFill>
                   <a:srgbClr val="183153"/>
@@ -4225,7 +4265,7 @@
                 <a:ea typeface="Arial"/>
                 <a:cs typeface="Arial"/>
               </a:rPr>
-              <a:t>Two communities, q buckets each.</a:t>
+              <a:t>Buckets carry assigned load.</a:t>
             </a:r>
           </a:p>
           <a:p xmlns:a="http://schemas.openxmlformats.org/drawingml/2006/main">
@@ -4234,7 +4274,8 @@
             </a:r>
           </a:p>
           <a:p xmlns:a="http://schemas.openxmlformats.org/drawingml/2006/main">
-            <a:pPr>
+            <a:pPr algn="l">
+              <a:buNone/>
               <a:defRPr sz="1875" b="0">
                 <a:solidFill>
                   <a:srgbClr val="183153"/>
@@ -4253,7 +4294,7 @@
                 <a:ea typeface="Arial"/>
                 <a:cs typeface="Arial"/>
               </a:rPr>
-              <a:t>Choose the less loaded candidate.</a:t>
+              <a:t>Communities group the buckets.</a:t>
             </a:r>
           </a:p>
           <a:p xmlns:a="http://schemas.openxmlformats.org/drawingml/2006/main">
@@ -4262,7 +4303,8 @@
             </a:r>
           </a:p>
           <a:p xmlns:a="http://schemas.openxmlformats.org/drawingml/2006/main">
-            <a:pPr>
+            <a:pPr algn="l">
+              <a:buNone/>
               <a:defRPr sz="1875" b="0">
                 <a:solidFill>
                   <a:srgbClr val="183153"/>
@@ -4281,7 +4323,7 @@
                 <a:ea typeface="Arial"/>
                 <a:cs typeface="Arial"/>
               </a:rPr>
-              <a:t>At critical fill: n* = 2qc.</a:t>
+              <a:t>Candidate edges limit comparisons.</a:t>
             </a:r>
           </a:p>
           <a:p xmlns:a="http://schemas.openxmlformats.org/drawingml/2006/main">
@@ -4290,7 +4332,8 @@
             </a:r>
           </a:p>
           <a:p xmlns:a="http://schemas.openxmlformats.org/drawingml/2006/main">
-            <a:pPr>
+            <a:pPr algn="l">
+              <a:buNone/>
               <a:defRPr sz="1875" b="0">
                 <a:solidFill>
                   <a:srgbClr val="183153"/>
@@ -4309,7 +4352,7 @@
                 <a:ea typeface="Arial"/>
                 <a:cs typeface="Arial"/>
               </a:rPr>
-              <a:t>Weak coupling: εq → λ &lt; ∞.</a:t>
+              <a:t>Overflow counts load above c.</a:t>
             </a:r>
           </a:p>
         </p:txBody>
@@ -4344,7 +4387,7 @@
         <p:txBody>
           <a:bodyPr xmlns:a="http://schemas.openxmlformats.org/drawingml/2006/main"/>
           <a:lstStyle xmlns:a="http://schemas.openxmlformats.org/drawingml/2006/main">
-            <a:defPPr>
+            <a:defPPr algn="l">
               <a:defRPr sz="1500" b="0">
                 <a:solidFill>
                   <a:srgbClr val="526071"/>
@@ -4354,7 +4397,8 @@
                 <a:cs typeface="Arial"/>
               </a:defRPr>
             </a:defPPr>
-            <a:lvl1pPr>
+            <a:lvl1pPr algn="l">
+              <a:buNone/>
               <a:defRPr sz="1500" b="0">
                 <a:solidFill>
                   <a:srgbClr val="526071"/>
@@ -4364,7 +4408,8 @@
                 <a:cs typeface="Arial"/>
               </a:defRPr>
             </a:lvl1pPr>
-            <a:lvl2pPr>
+            <a:lvl2pPr algn="l">
+              <a:buNone/>
               <a:defRPr sz="1500" b="0">
                 <a:solidFill>
                   <a:srgbClr val="526071"/>
@@ -4374,7 +4419,8 @@
                 <a:cs typeface="Arial"/>
               </a:defRPr>
             </a:lvl2pPr>
-            <a:lvl3pPr>
+            <a:lvl3pPr algn="l">
+              <a:buNone/>
               <a:defRPr sz="1500" b="0">
                 <a:solidFill>
                   <a:srgbClr val="526071"/>
@@ -4384,7 +4430,8 @@
                 <a:cs typeface="Arial"/>
               </a:defRPr>
             </a:lvl3pPr>
-            <a:lvl4pPr>
+            <a:lvl4pPr algn="l">
+              <a:buNone/>
               <a:defRPr sz="1500" b="0">
                 <a:solidFill>
                   <a:srgbClr val="526071"/>
@@ -4394,7 +4441,8 @@
                 <a:cs typeface="Arial"/>
               </a:defRPr>
             </a:lvl4pPr>
-            <a:lvl5pPr>
+            <a:lvl5pPr algn="l">
+              <a:buNone/>
               <a:defRPr sz="1500" b="0">
                 <a:solidFill>
                   <a:srgbClr val="526071"/>
@@ -4404,7 +4452,8 @@
                 <a:cs typeface="Arial"/>
               </a:defRPr>
             </a:lvl5pPr>
-            <a:lvl6pPr>
+            <a:lvl6pPr algn="l">
+              <a:buNone/>
               <a:defRPr sz="1500" b="0">
                 <a:solidFill>
                   <a:srgbClr val="526071"/>
@@ -4414,7 +4463,8 @@
                 <a:cs typeface="Arial"/>
               </a:defRPr>
             </a:lvl6pPr>
-            <a:lvl7pPr>
+            <a:lvl7pPr algn="l">
+              <a:buNone/>
               <a:defRPr sz="1500" b="0">
                 <a:solidFill>
                   <a:srgbClr val="526071"/>
@@ -4424,7 +4474,8 @@
                 <a:cs typeface="Arial"/>
               </a:defRPr>
             </a:lvl7pPr>
-            <a:lvl8pPr>
+            <a:lvl8pPr algn="l">
+              <a:buNone/>
               <a:defRPr sz="1500" b="0">
                 <a:solidFill>
                   <a:srgbClr val="526071"/>
@@ -4434,7 +4485,8 @@
                 <a:cs typeface="Arial"/>
               </a:defRPr>
             </a:lvl8pPr>
-            <a:lvl9pPr>
+            <a:lvl9pPr algn="l">
+              <a:buNone/>
               <a:defRPr sz="1500" b="0">
                 <a:solidFill>
                   <a:srgbClr val="526071"/>
@@ -4446,7 +4498,8 @@
             </a:lvl9pPr>
           </a:lstStyle>
           <a:p xmlns:a="http://schemas.openxmlformats.org/drawingml/2006/main">
-            <a:pPr>
+            <a:pPr algn="l">
+              <a:buNone/>
               <a:defRPr sz="1500" b="0">
                 <a:solidFill>
                   <a:srgbClr val="526071"/>
@@ -4465,7 +4518,7 @@
                 <a:ea typeface="Arial"/>
                 <a:cs typeface="Arial"/>
               </a:rPr>
-              <a:t>Model: uniform internal bipartite sampling, fixed cross kernels with uniform marginals, left-favored ties, empty start.</a:t>
+              <a:t>At critical fill, internal load variation contributes a positive order-q term beyond community excess.</a:t>
             </a:r>
           </a:p>
         </p:txBody>
@@ -4529,7 +4582,7 @@
         <p:txBody>
           <a:bodyPr xmlns:a="http://schemas.openxmlformats.org/drawingml/2006/main"/>
           <a:lstStyle xmlns:a="http://schemas.openxmlformats.org/drawingml/2006/main">
-            <a:defPPr>
+            <a:defPPr algn="l">
               <a:defRPr sz="3150" b="1">
                 <a:solidFill>
                   <a:srgbClr val="183153"/>
@@ -4539,7 +4592,8 @@
                 <a:cs typeface="Arial"/>
               </a:defRPr>
             </a:defPPr>
-            <a:lvl1pPr>
+            <a:lvl1pPr algn="l">
+              <a:buNone/>
               <a:defRPr sz="3150" b="1">
                 <a:solidFill>
                   <a:srgbClr val="183153"/>
@@ -4549,7 +4603,8 @@
                 <a:cs typeface="Arial"/>
               </a:defRPr>
             </a:lvl1pPr>
-            <a:lvl2pPr>
+            <a:lvl2pPr algn="l">
+              <a:buNone/>
               <a:defRPr sz="3150" b="1">
                 <a:solidFill>
                   <a:srgbClr val="183153"/>
@@ -4559,7 +4614,8 @@
                 <a:cs typeface="Arial"/>
               </a:defRPr>
             </a:lvl2pPr>
-            <a:lvl3pPr>
+            <a:lvl3pPr algn="l">
+              <a:buNone/>
               <a:defRPr sz="3150" b="1">
                 <a:solidFill>
                   <a:srgbClr val="183153"/>
@@ -4569,7 +4625,8 @@
                 <a:cs typeface="Arial"/>
               </a:defRPr>
             </a:lvl3pPr>
-            <a:lvl4pPr>
+            <a:lvl4pPr algn="l">
+              <a:buNone/>
               <a:defRPr sz="3150" b="1">
                 <a:solidFill>
                   <a:srgbClr val="183153"/>
@@ -4579,7 +4636,8 @@
                 <a:cs typeface="Arial"/>
               </a:defRPr>
             </a:lvl4pPr>
-            <a:lvl5pPr>
+            <a:lvl5pPr algn="l">
+              <a:buNone/>
               <a:defRPr sz="3150" b="1">
                 <a:solidFill>
                   <a:srgbClr val="183153"/>
@@ -4589,7 +4647,8 @@
                 <a:cs typeface="Arial"/>
               </a:defRPr>
             </a:lvl5pPr>
-            <a:lvl6pPr>
+            <a:lvl6pPr algn="l">
+              <a:buNone/>
               <a:defRPr sz="3150" b="1">
                 <a:solidFill>
                   <a:srgbClr val="183153"/>
@@ -4599,7 +4658,8 @@
                 <a:cs typeface="Arial"/>
               </a:defRPr>
             </a:lvl6pPr>
-            <a:lvl7pPr>
+            <a:lvl7pPr algn="l">
+              <a:buNone/>
               <a:defRPr sz="3150" b="1">
                 <a:solidFill>
                   <a:srgbClr val="183153"/>
@@ -4609,7 +4669,8 @@
                 <a:cs typeface="Arial"/>
               </a:defRPr>
             </a:lvl7pPr>
-            <a:lvl8pPr>
+            <a:lvl8pPr algn="l">
+              <a:buNone/>
               <a:defRPr sz="3150" b="1">
                 <a:solidFill>
                   <a:srgbClr val="183153"/>
@@ -4619,7 +4680,8 @@
                 <a:cs typeface="Arial"/>
               </a:defRPr>
             </a:lvl8pPr>
-            <a:lvl9pPr>
+            <a:lvl9pPr algn="l">
+              <a:buNone/>
               <a:defRPr sz="3150" b="1">
                 <a:solidFill>
                   <a:srgbClr val="183153"/>
@@ -4631,7 +4693,8 @@
             </a:lvl9pPr>
           </a:lstStyle>
           <a:p xmlns:a="http://schemas.openxmlformats.org/drawingml/2006/main">
-            <a:pPr>
+            <a:pPr algn="l">
+              <a:buNone/>
               <a:defRPr sz="3150" b="1">
                 <a:solidFill>
                   <a:srgbClr val="183153"/>
@@ -4650,7 +4713,7 @@
                 <a:ea typeface="Arial"/>
                 <a:cs typeface="Arial"/>
               </a:rPr>
-              <a:t>Community totals miss internal overflow</a:t>
+              <a:t>Internal overflow changes the leading capacity cost</a:t>
             </a:r>
           </a:p>
         </p:txBody>
@@ -4685,7 +4748,7 @@
         <p:txBody>
           <a:bodyPr xmlns:a="http://schemas.openxmlformats.org/drawingml/2006/main"/>
           <a:lstStyle xmlns:a="http://schemas.openxmlformats.org/drawingml/2006/main">
-            <a:defPPr>
+            <a:defPPr algn="l">
               <a:defRPr sz="2250" b="0">
                 <a:solidFill>
                   <a:srgbClr val="183153"/>
@@ -4695,7 +4758,8 @@
                 <a:cs typeface="Arial"/>
               </a:defRPr>
             </a:defPPr>
-            <a:lvl1pPr>
+            <a:lvl1pPr algn="l">
+              <a:buNone/>
               <a:defRPr sz="2250" b="0">
                 <a:solidFill>
                   <a:srgbClr val="183153"/>
@@ -4705,7 +4769,8 @@
                 <a:cs typeface="Arial"/>
               </a:defRPr>
             </a:lvl1pPr>
-            <a:lvl2pPr>
+            <a:lvl2pPr algn="l">
+              <a:buNone/>
               <a:defRPr sz="2250" b="0">
                 <a:solidFill>
                   <a:srgbClr val="183153"/>
@@ -4715,7 +4780,8 @@
                 <a:cs typeface="Arial"/>
               </a:defRPr>
             </a:lvl2pPr>
-            <a:lvl3pPr>
+            <a:lvl3pPr algn="l">
+              <a:buNone/>
               <a:defRPr sz="2250" b="0">
                 <a:solidFill>
                   <a:srgbClr val="183153"/>
@@ -4725,7 +4791,8 @@
                 <a:cs typeface="Arial"/>
               </a:defRPr>
             </a:lvl3pPr>
-            <a:lvl4pPr>
+            <a:lvl4pPr algn="l">
+              <a:buNone/>
               <a:defRPr sz="2250" b="0">
                 <a:solidFill>
                   <a:srgbClr val="183153"/>
@@ -4735,7 +4802,8 @@
                 <a:cs typeface="Arial"/>
               </a:defRPr>
             </a:lvl4pPr>
-            <a:lvl5pPr>
+            <a:lvl5pPr algn="l">
+              <a:buNone/>
               <a:defRPr sz="2250" b="0">
                 <a:solidFill>
                   <a:srgbClr val="183153"/>
@@ -4745,7 +4813,8 @@
                 <a:cs typeface="Arial"/>
               </a:defRPr>
             </a:lvl5pPr>
-            <a:lvl6pPr>
+            <a:lvl6pPr algn="l">
+              <a:buNone/>
               <a:defRPr sz="2250" b="0">
                 <a:solidFill>
                   <a:srgbClr val="183153"/>
@@ -4755,7 +4824,8 @@
                 <a:cs typeface="Arial"/>
               </a:defRPr>
             </a:lvl6pPr>
-            <a:lvl7pPr>
+            <a:lvl7pPr algn="l">
+              <a:buNone/>
               <a:defRPr sz="2250" b="0">
                 <a:solidFill>
                   <a:srgbClr val="183153"/>
@@ -4765,7 +4835,8 @@
                 <a:cs typeface="Arial"/>
               </a:defRPr>
             </a:lvl7pPr>
-            <a:lvl8pPr>
+            <a:lvl8pPr algn="l">
+              <a:buNone/>
               <a:defRPr sz="2250" b="0">
                 <a:solidFill>
                   <a:srgbClr val="183153"/>
@@ -4775,7 +4846,8 @@
                 <a:cs typeface="Arial"/>
               </a:defRPr>
             </a:lvl8pPr>
-            <a:lvl9pPr>
+            <a:lvl9pPr algn="l">
+              <a:buNone/>
               <a:defRPr sz="2250" b="0">
                 <a:solidFill>
                   <a:srgbClr val="183153"/>
@@ -4787,7 +4859,8 @@
             </a:lvl9pPr>
           </a:lstStyle>
           <a:p xmlns:a="http://schemas.openxmlformats.org/drawingml/2006/main">
-            <a:pPr>
+            <a:pPr algn="l">
+              <a:buNone/>
               <a:defRPr sz="2250" b="0">
                 <a:solidFill>
                   <a:srgbClr val="183153"/>
@@ -4806,7 +4879,7 @@
                 <a:ea typeface="Arial"/>
                 <a:cs typeface="Arial"/>
               </a:rPr>
-              <a:t>The internal load profile adds a strictly positive order-q contribution at nominal capacity.</a:t>
+              <a:t>A joint critical law retains community imbalance and the internal load profile.</a:t>
             </a:r>
           </a:p>
         </p:txBody>
@@ -4816,7 +4889,7 @@
           <p:cNvPr id="3" name="">
             <a:extLst xmlns:a="http://schemas.openxmlformats.org/drawingml/2006/main">
               <a:ext uri="{FF2B5EF4-FFF2-40B4-BE49-F238E27FC236}">
-                <a16:creationId xmlns:a16="http://schemas.microsoft.com/office/drawing/2014/main" id="{387BAC71-EAC5-4E74-ADA4-0550B050DF37}"/>
+                <a16:creationId xmlns:a16="http://schemas.microsoft.com/office/drawing/2014/main" id="{F4F3800D-F429-430E-B2EA-AD888AAC657C}"/>
               </a:ext>
             </a:extLst>
           </p:cNvPr>
@@ -4826,7 +4899,7 @@
           <p:nvPr/>
         </p:nvPicPr>
         <p:blipFill>
-          <a:blip xmlns:r="http://schemas.openxmlformats.org/officeDocument/2006/relationships" xmlns:a="http://schemas.openxmlformats.org/drawingml/2006/main" r:embed="R44ce0f9eccfa4819"/>
+          <a:blip xmlns:r="http://schemas.openxmlformats.org/officeDocument/2006/relationships" xmlns:a="http://schemas.openxmlformats.org/drawingml/2006/main" r:embed="R0ec6a0dd667d422d"/>
           <a:stretch xmlns:a="http://schemas.openxmlformats.org/drawingml/2006/main"/>
         </p:blipFill>
         <p:spPr>
@@ -4869,7 +4942,7 @@
         <p:txBody>
           <a:bodyPr xmlns:a="http://schemas.openxmlformats.org/drawingml/2006/main"/>
           <a:lstStyle xmlns:a="http://schemas.openxmlformats.org/drawingml/2006/main">
-            <a:defPPr>
+            <a:defPPr algn="l">
               <a:defRPr sz="1950" b="0">
                 <a:solidFill>
                   <a:srgbClr val="183153"/>
@@ -4879,7 +4952,8 @@
                 <a:cs typeface="Arial"/>
               </a:defRPr>
             </a:defPPr>
-            <a:lvl1pPr>
+            <a:lvl1pPr algn="l">
+              <a:buNone/>
               <a:defRPr sz="1950" b="0">
                 <a:solidFill>
                   <a:srgbClr val="183153"/>
@@ -4889,7 +4963,8 @@
                 <a:cs typeface="Arial"/>
               </a:defRPr>
             </a:lvl1pPr>
-            <a:lvl2pPr>
+            <a:lvl2pPr algn="l">
+              <a:buNone/>
               <a:defRPr sz="1950" b="0">
                 <a:solidFill>
                   <a:srgbClr val="183153"/>
@@ -4899,7 +4974,8 @@
                 <a:cs typeface="Arial"/>
               </a:defRPr>
             </a:lvl2pPr>
-            <a:lvl3pPr>
+            <a:lvl3pPr algn="l">
+              <a:buNone/>
               <a:defRPr sz="1950" b="0">
                 <a:solidFill>
                   <a:srgbClr val="183153"/>
@@ -4909,7 +4985,8 @@
                 <a:cs typeface="Arial"/>
               </a:defRPr>
             </a:lvl3pPr>
-            <a:lvl4pPr>
+            <a:lvl4pPr algn="l">
+              <a:buNone/>
               <a:defRPr sz="1950" b="0">
                 <a:solidFill>
                   <a:srgbClr val="183153"/>
@@ -4919,7 +4996,8 @@
                 <a:cs typeface="Arial"/>
               </a:defRPr>
             </a:lvl4pPr>
-            <a:lvl5pPr>
+            <a:lvl5pPr algn="l">
+              <a:buNone/>
               <a:defRPr sz="1950" b="0">
                 <a:solidFill>
                   <a:srgbClr val="183153"/>
@@ -4929,7 +5007,8 @@
                 <a:cs typeface="Arial"/>
               </a:defRPr>
             </a:lvl5pPr>
-            <a:lvl6pPr>
+            <a:lvl6pPr algn="l">
+              <a:buNone/>
               <a:defRPr sz="1950" b="0">
                 <a:solidFill>
                   <a:srgbClr val="183153"/>
@@ -4939,7 +5018,8 @@
                 <a:cs typeface="Arial"/>
               </a:defRPr>
             </a:lvl6pPr>
-            <a:lvl7pPr>
+            <a:lvl7pPr algn="l">
+              <a:buNone/>
               <a:defRPr sz="1950" b="0">
                 <a:solidFill>
                   <a:srgbClr val="183153"/>
@@ -4949,7 +5029,8 @@
                 <a:cs typeface="Arial"/>
               </a:defRPr>
             </a:lvl7pPr>
-            <a:lvl8pPr>
+            <a:lvl8pPr algn="l">
+              <a:buNone/>
               <a:defRPr sz="1950" b="0">
                 <a:solidFill>
                   <a:srgbClr val="183153"/>
@@ -4959,7 +5040,8 @@
                 <a:cs typeface="Arial"/>
               </a:defRPr>
             </a:lvl8pPr>
-            <a:lvl9pPr>
+            <a:lvl9pPr algn="l">
+              <a:buNone/>
               <a:defRPr sz="1950" b="0">
                 <a:solidFill>
                   <a:srgbClr val="183153"/>
@@ -4971,7 +5053,8 @@
             </a:lvl9pPr>
           </a:lstStyle>
           <a:p xmlns:a="http://schemas.openxmlformats.org/drawingml/2006/main">
-            <a:pPr>
+            <a:pPr algn="l">
+              <a:buNone/>
               <a:defRPr sz="1950" b="0">
                 <a:solidFill>
                   <a:srgbClr val="183153"/>
@@ -4990,7 +5073,31 @@
                 <a:ea typeface="Arial"/>
                 <a:cs typeface="Arial"/>
               </a:rPr>
-              <a:t>Even at zero normalized imbalance, the limiting overflow coefficient lies in [0.63127654, 0.63129462].</a:t>
+              <a:t>Expected overflow is order q at nominal capacity.</a:t>
+            </a:r>
+          </a:p>
+          <a:p xmlns:a="http://schemas.openxmlformats.org/drawingml/2006/main">
+            <a:pPr algn="l">
+              <a:buNone/>
+              <a:defRPr sz="1950" b="0">
+                <a:solidFill>
+                  <a:srgbClr val="183153"/>
+                </a:solidFill>
+                <a:latin typeface="Arial"/>
+                <a:ea typeface="Arial"/>
+                <a:cs typeface="Arial"/>
+              </a:defRPr>
+            </a:pPr>
+            <a:r>
+              <a:rPr sz="1950" b="0">
+                <a:solidFill>
+                  <a:srgbClr val="183153"/>
+                </a:solidFill>
+                <a:latin typeface="Arial"/>
+                <a:ea typeface="Arial"/>
+                <a:cs typeface="Arial"/>
+              </a:rPr>
+              <a:t>At zero normalized imbalance, the profile readout is approximately 0.6313.</a:t>
             </a:r>
           </a:p>
         </p:txBody>
@@ -5054,7 +5161,7 @@
         <p:txBody>
           <a:bodyPr xmlns:a="http://schemas.openxmlformats.org/drawingml/2006/main"/>
           <a:lstStyle xmlns:a="http://schemas.openxmlformats.org/drawingml/2006/main">
-            <a:defPPr>
+            <a:defPPr algn="l">
               <a:defRPr sz="3150" b="1">
                 <a:solidFill>
                   <a:srgbClr val="183153"/>
@@ -5064,7 +5171,8 @@
                 <a:cs typeface="Arial"/>
               </a:defRPr>
             </a:defPPr>
-            <a:lvl1pPr>
+            <a:lvl1pPr algn="l">
+              <a:buNone/>
               <a:defRPr sz="3150" b="1">
                 <a:solidFill>
                   <a:srgbClr val="183153"/>
@@ -5074,7 +5182,8 @@
                 <a:cs typeface="Arial"/>
               </a:defRPr>
             </a:lvl1pPr>
-            <a:lvl2pPr>
+            <a:lvl2pPr algn="l">
+              <a:buNone/>
               <a:defRPr sz="3150" b="1">
                 <a:solidFill>
                   <a:srgbClr val="183153"/>
@@ -5084,7 +5193,8 @@
                 <a:cs typeface="Arial"/>
               </a:defRPr>
             </a:lvl2pPr>
-            <a:lvl3pPr>
+            <a:lvl3pPr algn="l">
+              <a:buNone/>
               <a:defRPr sz="3150" b="1">
                 <a:solidFill>
                   <a:srgbClr val="183153"/>
@@ -5094,7 +5204,8 @@
                 <a:cs typeface="Arial"/>
               </a:defRPr>
             </a:lvl3pPr>
-            <a:lvl4pPr>
+            <a:lvl4pPr algn="l">
+              <a:buNone/>
               <a:defRPr sz="3150" b="1">
                 <a:solidFill>
                   <a:srgbClr val="183153"/>
@@ -5104,7 +5215,8 @@
                 <a:cs typeface="Arial"/>
               </a:defRPr>
             </a:lvl4pPr>
-            <a:lvl5pPr>
+            <a:lvl5pPr algn="l">
+              <a:buNone/>
               <a:defRPr sz="3150" b="1">
                 <a:solidFill>
                   <a:srgbClr val="183153"/>
@@ -5114,7 +5226,8 @@
                 <a:cs typeface="Arial"/>
               </a:defRPr>
             </a:lvl5pPr>
-            <a:lvl6pPr>
+            <a:lvl6pPr algn="l">
+              <a:buNone/>
               <a:defRPr sz="3150" b="1">
                 <a:solidFill>
                   <a:srgbClr val="183153"/>
@@ -5124,7 +5237,8 @@
                 <a:cs typeface="Arial"/>
               </a:defRPr>
             </a:lvl6pPr>
-            <a:lvl7pPr>
+            <a:lvl7pPr algn="l">
+              <a:buNone/>
               <a:defRPr sz="3150" b="1">
                 <a:solidFill>
                   <a:srgbClr val="183153"/>
@@ -5134,7 +5248,8 @@
                 <a:cs typeface="Arial"/>
               </a:defRPr>
             </a:lvl7pPr>
-            <a:lvl8pPr>
+            <a:lvl8pPr algn="l">
+              <a:buNone/>
               <a:defRPr sz="3150" b="1">
                 <a:solidFill>
                   <a:srgbClr val="183153"/>
@@ -5144,7 +5259,8 @@
                 <a:cs typeface="Arial"/>
               </a:defRPr>
             </a:lvl8pPr>
-            <a:lvl9pPr>
+            <a:lvl9pPr algn="l">
+              <a:buNone/>
               <a:defRPr sz="3150" b="1">
                 <a:solidFill>
                   <a:srgbClr val="183153"/>
@@ -5156,7 +5272,8 @@
             </a:lvl9pPr>
           </a:lstStyle>
           <a:p xmlns:a="http://schemas.openxmlformats.org/drawingml/2006/main">
-            <a:pPr>
+            <a:pPr algn="l">
+              <a:buNone/>
               <a:defRPr sz="3150" b="1">
                 <a:solidFill>
                   <a:srgbClr val="183153"/>
@@ -5175,7 +5292,7 @@
                 <a:ea typeface="Arial"/>
                 <a:cs typeface="Arial"/>
               </a:rPr>
-              <a:t>Fixed cross kernels share the critical law</a:t>
+              <a:t>Topological amplification of internal overflow</a:t>
             </a:r>
           </a:p>
         </p:txBody>
@@ -5197,7 +5314,7 @@
         <p:spPr>
           <a:xfrm xmlns:a="http://schemas.openxmlformats.org/drawingml/2006/main">
             <a:off x="609600" y="1257300"/>
-            <a:ext cx="10972800" cy="666750"/>
+            <a:ext cx="10972800" cy="457200"/>
           </a:xfrm>
           <a:prstGeom xmlns:a="http://schemas.openxmlformats.org/drawingml/2006/main" prst="rect">
             <a:avLst/>
@@ -5210,7 +5327,18 @@
         <p:txBody>
           <a:bodyPr xmlns:a="http://schemas.openxmlformats.org/drawingml/2006/main"/>
           <a:lstStyle xmlns:a="http://schemas.openxmlformats.org/drawingml/2006/main">
-            <a:defPPr>
+            <a:defPPr algn="l">
+              <a:defRPr sz="2100" b="0">
+                <a:solidFill>
+                  <a:srgbClr val="183153"/>
+                </a:solidFill>
+                <a:latin typeface="Arial"/>
+                <a:ea typeface="Arial"/>
+                <a:cs typeface="Arial"/>
+              </a:defRPr>
+            </a:defPPr>
+            <a:lvl1pPr algn="l">
+              <a:buNone/>
               <a:defRPr sz="2250" b="0">
                 <a:solidFill>
                   <a:srgbClr val="183153"/>
@@ -5219,8 +5347,9 @@
                 <a:ea typeface="Arial"/>
                 <a:cs typeface="Arial"/>
               </a:defRPr>
-            </a:defPPr>
-            <a:lvl1pPr>
+            </a:lvl1pPr>
+            <a:lvl2pPr algn="l">
+              <a:buNone/>
               <a:defRPr sz="2250" b="0">
                 <a:solidFill>
                   <a:srgbClr val="183153"/>
@@ -5229,8 +5358,9 @@
                 <a:ea typeface="Arial"/>
                 <a:cs typeface="Arial"/>
               </a:defRPr>
-            </a:lvl1pPr>
-            <a:lvl2pPr>
+            </a:lvl2pPr>
+            <a:lvl3pPr algn="l">
+              <a:buNone/>
               <a:defRPr sz="2250" b="0">
                 <a:solidFill>
                   <a:srgbClr val="183153"/>
@@ -5239,8 +5369,9 @@
                 <a:ea typeface="Arial"/>
                 <a:cs typeface="Arial"/>
               </a:defRPr>
-            </a:lvl2pPr>
-            <a:lvl3pPr>
+            </a:lvl3pPr>
+            <a:lvl4pPr algn="l">
+              <a:buNone/>
               <a:defRPr sz="2250" b="0">
                 <a:solidFill>
                   <a:srgbClr val="183153"/>
@@ -5249,8 +5380,9 @@
                 <a:ea typeface="Arial"/>
                 <a:cs typeface="Arial"/>
               </a:defRPr>
-            </a:lvl3pPr>
-            <a:lvl4pPr>
+            </a:lvl4pPr>
+            <a:lvl5pPr algn="l">
+              <a:buNone/>
               <a:defRPr sz="2250" b="0">
                 <a:solidFill>
                   <a:srgbClr val="183153"/>
@@ -5259,8 +5391,9 @@
                 <a:ea typeface="Arial"/>
                 <a:cs typeface="Arial"/>
               </a:defRPr>
-            </a:lvl4pPr>
-            <a:lvl5pPr>
+            </a:lvl5pPr>
+            <a:lvl6pPr algn="l">
+              <a:buNone/>
               <a:defRPr sz="2250" b="0">
                 <a:solidFill>
                   <a:srgbClr val="183153"/>
@@ -5269,8 +5402,9 @@
                 <a:ea typeface="Arial"/>
                 <a:cs typeface="Arial"/>
               </a:defRPr>
-            </a:lvl5pPr>
-            <a:lvl6pPr>
+            </a:lvl6pPr>
+            <a:lvl7pPr algn="l">
+              <a:buNone/>
               <a:defRPr sz="2250" b="0">
                 <a:solidFill>
                   <a:srgbClr val="183153"/>
@@ -5279,8 +5413,9 @@
                 <a:ea typeface="Arial"/>
                 <a:cs typeface="Arial"/>
               </a:defRPr>
-            </a:lvl6pPr>
-            <a:lvl7pPr>
+            </a:lvl7pPr>
+            <a:lvl8pPr algn="l">
+              <a:buNone/>
               <a:defRPr sz="2250" b="0">
                 <a:solidFill>
                   <a:srgbClr val="183153"/>
@@ -5289,18 +5424,9 @@
                 <a:ea typeface="Arial"/>
                 <a:cs typeface="Arial"/>
               </a:defRPr>
-            </a:lvl7pPr>
-            <a:lvl8pPr>
-              <a:defRPr sz="2250" b="0">
-                <a:solidFill>
-                  <a:srgbClr val="183153"/>
-                </a:solidFill>
-                <a:latin typeface="Arial"/>
-                <a:ea typeface="Arial"/>
-                <a:cs typeface="Arial"/>
-              </a:defRPr>
             </a:lvl8pPr>
-            <a:lvl9pPr>
+            <a:lvl9pPr algn="l">
+              <a:buNone/>
               <a:defRPr sz="2250" b="0">
                 <a:solidFill>
                   <a:srgbClr val="183153"/>
@@ -5312,8 +5438,9 @@
             </a:lvl9pPr>
           </a:lstStyle>
           <a:p xmlns:a="http://schemas.openxmlformats.org/drawingml/2006/main">
-            <a:pPr>
-              <a:defRPr sz="2250" b="0">
+            <a:pPr algn="l">
+              <a:buNone/>
+              <a:defRPr sz="2100" b="0">
                 <a:solidFill>
                   <a:srgbClr val="183153"/>
                 </a:solidFill>
@@ -5323,7 +5450,7 @@
               </a:defRPr>
             </a:pPr>
             <a:r>
-              <a:rPr sz="2250" b="0">
+              <a:rPr sz="2100" b="0">
                 <a:solidFill>
                   <a:srgbClr val="183153"/>
                 </a:solidFill>
@@ -5331,7 +5458,7 @@
                 <a:ea typeface="Arial"/>
                 <a:cs typeface="Arial"/>
               </a:rPr>
-              <a:t>A process coupling transfers the leading overflow law from product sampling to all admissible fixed kernels.</a:t>
+              <a:t>Mean omitted overflow reaches 5.8× for cycles and 21.4× for matchings.</a:t>
             </a:r>
           </a:p>
         </p:txBody>
@@ -5341,7 +5468,7 @@
           <p:cNvPr id="3" name="">
             <a:extLst xmlns:a="http://schemas.openxmlformats.org/drawingml/2006/main">
               <a:ext uri="{FF2B5EF4-FFF2-40B4-BE49-F238E27FC236}">
-                <a16:creationId xmlns:a16="http://schemas.microsoft.com/office/drawing/2014/main" id="{C51FCE08-B658-4C1D-9153-5F7C27146BB1}"/>
+                <a16:creationId xmlns:a16="http://schemas.microsoft.com/office/drawing/2014/main" id="{9E50C403-5544-482D-9A7E-0CDA62DCFA7C}"/>
               </a:ext>
             </a:extLst>
           </p:cNvPr>
@@ -5351,13 +5478,14 @@
           <p:nvPr/>
         </p:nvPicPr>
         <p:blipFill>
-          <a:blip xmlns:r="http://schemas.openxmlformats.org/officeDocument/2006/relationships" xmlns:a="http://schemas.openxmlformats.org/drawingml/2006/main" r:embed="R5b1db343f4b34baf"/>
+          <a:blip xmlns:r="http://schemas.openxmlformats.org/officeDocument/2006/relationships" xmlns:a="http://schemas.openxmlformats.org/drawingml/2006/main" r:embed="Rc2f1d5abaa154f30"/>
+          <a:srcRect xmlns:a="http://schemas.openxmlformats.org/drawingml/2006/main" l="0" t="0" r="0" b="0"/>
           <a:stretch xmlns:a="http://schemas.openxmlformats.org/drawingml/2006/main"/>
         </p:blipFill>
         <p:spPr>
           <a:xfrm xmlns:a="http://schemas.openxmlformats.org/drawingml/2006/main">
-            <a:off x="609600" y="2544861"/>
-            <a:ext cx="5953125" cy="2549327"/>
+            <a:off x="1752600" y="1771650"/>
+            <a:ext cx="8686800" cy="3619500"/>
           </a:xfrm>
           <a:prstGeom xmlns:a="http://schemas.openxmlformats.org/drawingml/2006/main" prst="rect">
             <a:avLst/>
@@ -5380,8 +5508,8 @@
         </p:nvSpPr>
         <p:spPr>
           <a:xfrm xmlns:a="http://schemas.openxmlformats.org/drawingml/2006/main">
-            <a:off x="7124700" y="2362200"/>
-            <a:ext cx="4457700" cy="2628900"/>
+            <a:off x="609600" y="5391150"/>
+            <a:ext cx="10972800" cy="304800"/>
           </a:xfrm>
           <a:prstGeom xmlns:a="http://schemas.openxmlformats.org/drawingml/2006/main" prst="rect">
             <a:avLst/>
@@ -5394,7 +5522,18 @@
         <p:txBody>
           <a:bodyPr xmlns:a="http://schemas.openxmlformats.org/drawingml/2006/main"/>
           <a:lstStyle xmlns:a="http://schemas.openxmlformats.org/drawingml/2006/main">
-            <a:defPPr>
+            <a:defPPr algn="l">
+              <a:defRPr sz="1500" b="0">
+                <a:solidFill>
+                  <a:srgbClr val="526071"/>
+                </a:solidFill>
+                <a:latin typeface="Arial"/>
+                <a:ea typeface="Arial"/>
+                <a:cs typeface="Arial"/>
+              </a:defRPr>
+            </a:defPPr>
+            <a:lvl1pPr algn="l">
+              <a:buNone/>
               <a:defRPr sz="2025" b="0">
                 <a:solidFill>
                   <a:srgbClr val="183153"/>
@@ -5403,8 +5542,9 @@
                 <a:ea typeface="Arial"/>
                 <a:cs typeface="Arial"/>
               </a:defRPr>
-            </a:defPPr>
-            <a:lvl1pPr>
+            </a:lvl1pPr>
+            <a:lvl2pPr algn="l">
+              <a:buNone/>
               <a:defRPr sz="2025" b="0">
                 <a:solidFill>
                   <a:srgbClr val="183153"/>
@@ -5413,8 +5553,9 @@
                 <a:ea typeface="Arial"/>
                 <a:cs typeface="Arial"/>
               </a:defRPr>
-            </a:lvl1pPr>
-            <a:lvl2pPr>
+            </a:lvl2pPr>
+            <a:lvl3pPr algn="l">
+              <a:buNone/>
               <a:defRPr sz="2025" b="0">
                 <a:solidFill>
                   <a:srgbClr val="183153"/>
@@ -5423,8 +5564,9 @@
                 <a:ea typeface="Arial"/>
                 <a:cs typeface="Arial"/>
               </a:defRPr>
-            </a:lvl2pPr>
-            <a:lvl3pPr>
+            </a:lvl3pPr>
+            <a:lvl4pPr algn="l">
+              <a:buNone/>
               <a:defRPr sz="2025" b="0">
                 <a:solidFill>
                   <a:srgbClr val="183153"/>
@@ -5433,8 +5575,9 @@
                 <a:ea typeface="Arial"/>
                 <a:cs typeface="Arial"/>
               </a:defRPr>
-            </a:lvl3pPr>
-            <a:lvl4pPr>
+            </a:lvl4pPr>
+            <a:lvl5pPr algn="l">
+              <a:buNone/>
               <a:defRPr sz="2025" b="0">
                 <a:solidFill>
                   <a:srgbClr val="183153"/>
@@ -5443,8 +5586,9 @@
                 <a:ea typeface="Arial"/>
                 <a:cs typeface="Arial"/>
               </a:defRPr>
-            </a:lvl4pPr>
-            <a:lvl5pPr>
+            </a:lvl5pPr>
+            <a:lvl6pPr algn="l">
+              <a:buNone/>
               <a:defRPr sz="2025" b="0">
                 <a:solidFill>
                   <a:srgbClr val="183153"/>
@@ -5453,8 +5597,9 @@
                 <a:ea typeface="Arial"/>
                 <a:cs typeface="Arial"/>
               </a:defRPr>
-            </a:lvl5pPr>
-            <a:lvl6pPr>
+            </a:lvl6pPr>
+            <a:lvl7pPr algn="l">
+              <a:buNone/>
               <a:defRPr sz="2025" b="0">
                 <a:solidFill>
                   <a:srgbClr val="183153"/>
@@ -5463,8 +5608,9 @@
                 <a:ea typeface="Arial"/>
                 <a:cs typeface="Arial"/>
               </a:defRPr>
-            </a:lvl6pPr>
-            <a:lvl7pPr>
+            </a:lvl7pPr>
+            <a:lvl8pPr algn="l">
+              <a:buNone/>
               <a:defRPr sz="2025" b="0">
                 <a:solidFill>
                   <a:srgbClr val="183153"/>
@@ -5473,18 +5619,9 @@
                 <a:ea typeface="Arial"/>
                 <a:cs typeface="Arial"/>
               </a:defRPr>
-            </a:lvl7pPr>
-            <a:lvl8pPr>
-              <a:defRPr sz="2025" b="0">
-                <a:solidFill>
-                  <a:srgbClr val="183153"/>
-                </a:solidFill>
-                <a:latin typeface="Arial"/>
-                <a:ea typeface="Arial"/>
-                <a:cs typeface="Arial"/>
-              </a:defRPr>
             </a:lvl8pPr>
-            <a:lvl9pPr>
+            <a:lvl9pPr algn="l">
+              <a:buNone/>
               <a:defRPr sz="2025" b="0">
                 <a:solidFill>
                   <a:srgbClr val="183153"/>
@@ -5496,10 +5633,11 @@
             </a:lvl9pPr>
           </a:lstStyle>
           <a:p xmlns:a="http://schemas.openxmlformats.org/drawingml/2006/main">
-            <a:pPr>
-              <a:defRPr sz="2025" b="0">
-                <a:solidFill>
-                  <a:srgbClr val="183153"/>
+            <a:pPr algn="l">
+              <a:buNone/>
+              <a:defRPr sz="1500" b="0">
+                <a:solidFill>
+                  <a:srgbClr val="526071"/>
                 </a:solidFill>
                 <a:latin typeface="Arial"/>
                 <a:ea typeface="Arial"/>
@@ -5507,71 +5645,15 @@
               </a:defRPr>
             </a:pPr>
             <a:r>
-              <a:rPr sz="2025" b="0">
-                <a:solidFill>
-                  <a:srgbClr val="183153"/>
+              <a:rPr sz="1500" b="0">
+                <a:solidFill>
+                  <a:srgbClr val="526071"/>
                 </a:solidFill>
                 <a:latin typeface="Arial"/>
                 <a:ea typeface="Arial"/>
                 <a:cs typeface="Arial"/>
               </a:rPr>
-              <a:t>A scalar diffusion describes imbalance.</a:t>
-            </a:r>
-          </a:p>
-          <a:p xmlns:a="http://schemas.openxmlformats.org/drawingml/2006/main">
-            <a:r>
-              <a:t/>
-            </a:r>
-          </a:p>
-          <a:p xmlns:a="http://schemas.openxmlformats.org/drawingml/2006/main">
-            <a:pPr>
-              <a:defRPr sz="2025" b="0">
-                <a:solidFill>
-                  <a:srgbClr val="183153"/>
-                </a:solidFill>
-                <a:latin typeface="Arial"/>
-                <a:ea typeface="Arial"/>
-                <a:cs typeface="Arial"/>
-              </a:defRPr>
-            </a:pPr>
-            <a:r>
-              <a:rPr sz="2025" b="0">
-                <a:solidFill>
-                  <a:srgbClr val="183153"/>
-                </a:solidFill>
-                <a:latin typeface="Arial"/>
-                <a:ea typeface="Arial"/>
-                <a:cs typeface="Arial"/>
-              </a:rPr>
-              <a:t>The diffusion drift averages the lattice phase.</a:t>
-            </a:r>
-          </a:p>
-          <a:p xmlns:a="http://schemas.openxmlformats.org/drawingml/2006/main">
-            <a:r>
-              <a:t/>
-            </a:r>
-          </a:p>
-          <a:p xmlns:a="http://schemas.openxmlformats.org/drawingml/2006/main">
-            <a:pPr>
-              <a:defRPr sz="2025" b="0">
-                <a:solidFill>
-                  <a:srgbClr val="183153"/>
-                </a:solidFill>
-                <a:latin typeface="Arial"/>
-                <a:ea typeface="Arial"/>
-                <a:cs typeface="Arial"/>
-              </a:defRPr>
-            </a:pPr>
-            <a:r>
-              <a:rPr sz="2025" b="0">
-                <a:solidFill>
-                  <a:srgbClr val="183153"/>
-                </a:solidFill>
-                <a:latin typeface="Arial"/>
-                <a:ea typeface="Arial"/>
-                <a:cs typeface="Arial"/>
-              </a:rPr>
-              <a:t>Overflow retains the internal profile and observation phase.</a:t>
+              <a:t>Complete-bipartite baseline. q=512, κ=λ=1, left ties. Each cell has 1024 trajectories.</a:t>
             </a:r>
           </a:p>
         </p:txBody>
@@ -5592,8 +5674,8 @@
         </p:nvSpPr>
         <p:spPr>
           <a:xfrm xmlns:a="http://schemas.openxmlformats.org/drawingml/2006/main">
-            <a:off x="609600" y="5772150"/>
-            <a:ext cx="10972800" cy="619125"/>
+            <a:off x="609600" y="5829300"/>
+            <a:ext cx="10972800" cy="647700"/>
           </a:xfrm>
           <a:prstGeom xmlns:a="http://schemas.openxmlformats.org/drawingml/2006/main" prst="rect">
             <a:avLst/>
@@ -5606,7 +5688,18 @@
         <p:txBody>
           <a:bodyPr xmlns:a="http://schemas.openxmlformats.org/drawingml/2006/main"/>
           <a:lstStyle xmlns:a="http://schemas.openxmlformats.org/drawingml/2006/main">
-            <a:defPPr>
+            <a:defPPr algn="l">
+              <a:defRPr sz="1950" b="0">
+                <a:solidFill>
+                  <a:srgbClr val="183153"/>
+                </a:solidFill>
+                <a:latin typeface="Arial"/>
+                <a:ea typeface="Arial"/>
+                <a:cs typeface="Arial"/>
+              </a:defRPr>
+            </a:defPPr>
+            <a:lvl1pPr algn="l">
+              <a:buNone/>
               <a:defRPr sz="2100" b="0">
                 <a:solidFill>
                   <a:srgbClr val="183153"/>
@@ -5615,8 +5708,9 @@
                 <a:ea typeface="Arial"/>
                 <a:cs typeface="Arial"/>
               </a:defRPr>
-            </a:defPPr>
-            <a:lvl1pPr>
+            </a:lvl1pPr>
+            <a:lvl2pPr algn="l">
+              <a:buNone/>
               <a:defRPr sz="2100" b="0">
                 <a:solidFill>
                   <a:srgbClr val="183153"/>
@@ -5625,8 +5719,9 @@
                 <a:ea typeface="Arial"/>
                 <a:cs typeface="Arial"/>
               </a:defRPr>
-            </a:lvl1pPr>
-            <a:lvl2pPr>
+            </a:lvl2pPr>
+            <a:lvl3pPr algn="l">
+              <a:buNone/>
               <a:defRPr sz="2100" b="0">
                 <a:solidFill>
                   <a:srgbClr val="183153"/>
@@ -5635,8 +5730,9 @@
                 <a:ea typeface="Arial"/>
                 <a:cs typeface="Arial"/>
               </a:defRPr>
-            </a:lvl2pPr>
-            <a:lvl3pPr>
+            </a:lvl3pPr>
+            <a:lvl4pPr algn="l">
+              <a:buNone/>
               <a:defRPr sz="2100" b="0">
                 <a:solidFill>
                   <a:srgbClr val="183153"/>
@@ -5645,8 +5741,9 @@
                 <a:ea typeface="Arial"/>
                 <a:cs typeface="Arial"/>
               </a:defRPr>
-            </a:lvl3pPr>
-            <a:lvl4pPr>
+            </a:lvl4pPr>
+            <a:lvl5pPr algn="l">
+              <a:buNone/>
               <a:defRPr sz="2100" b="0">
                 <a:solidFill>
                   <a:srgbClr val="183153"/>
@@ -5655,8 +5752,9 @@
                 <a:ea typeface="Arial"/>
                 <a:cs typeface="Arial"/>
               </a:defRPr>
-            </a:lvl4pPr>
-            <a:lvl5pPr>
+            </a:lvl5pPr>
+            <a:lvl6pPr algn="l">
+              <a:buNone/>
               <a:defRPr sz="2100" b="0">
                 <a:solidFill>
                   <a:srgbClr val="183153"/>
@@ -5665,8 +5763,9 @@
                 <a:ea typeface="Arial"/>
                 <a:cs typeface="Arial"/>
               </a:defRPr>
-            </a:lvl5pPr>
-            <a:lvl6pPr>
+            </a:lvl6pPr>
+            <a:lvl7pPr algn="l">
+              <a:buNone/>
               <a:defRPr sz="2100" b="0">
                 <a:solidFill>
                   <a:srgbClr val="183153"/>
@@ -5675,8 +5774,9 @@
                 <a:ea typeface="Arial"/>
                 <a:cs typeface="Arial"/>
               </a:defRPr>
-            </a:lvl6pPr>
-            <a:lvl7pPr>
+            </a:lvl7pPr>
+            <a:lvl8pPr algn="l">
+              <a:buNone/>
               <a:defRPr sz="2100" b="0">
                 <a:solidFill>
                   <a:srgbClr val="183153"/>
@@ -5685,18 +5785,9 @@
                 <a:ea typeface="Arial"/>
                 <a:cs typeface="Arial"/>
               </a:defRPr>
-            </a:lvl7pPr>
-            <a:lvl8pPr>
-              <a:defRPr sz="2100" b="0">
-                <a:solidFill>
-                  <a:srgbClr val="183153"/>
-                </a:solidFill>
-                <a:latin typeface="Arial"/>
-                <a:ea typeface="Arial"/>
-                <a:cs typeface="Arial"/>
-              </a:defRPr>
             </a:lvl8pPr>
-            <a:lvl9pPr>
+            <a:lvl9pPr algn="l">
+              <a:buNone/>
               <a:defRPr sz="2100" b="0">
                 <a:solidFill>
                   <a:srgbClr val="183153"/>
@@ -5708,8 +5799,9 @@
             </a:lvl9pPr>
           </a:lstStyle>
           <a:p xmlns:a="http://schemas.openxmlformats.org/drawingml/2006/main">
-            <a:pPr>
-              <a:defRPr sz="2100" b="0">
+            <a:pPr algn="l">
+              <a:buNone/>
+              <a:defRPr sz="1950" b="0">
                 <a:solidFill>
                   <a:srgbClr val="183153"/>
                 </a:solidFill>
@@ -5719,7 +5811,7 @@
               </a:defRPr>
             </a:pPr>
             <a:r>
-              <a:rPr sz="2100" b="0">
+              <a:rPr sz="1950" b="0">
                 <a:solidFill>
                   <a:srgbClr val="183153"/>
                 </a:solidFill>
@@ -5727,7 +5819,31 @@
                 <a:ea typeface="Arial"/>
                 <a:cs typeface="Arial"/>
               </a:rPr>
-              <a:t>At nominal capacity: expected overflow is order q, while its fraction of arrivals tends to zero.</a:t>
+              <a:t>Capacity monitoring can retain excess load and unused capacity together,</a:t>
+            </a:r>
+          </a:p>
+          <a:p xmlns:a="http://schemas.openxmlformats.org/drawingml/2006/main">
+            <a:pPr algn="l">
+              <a:buNone/>
+              <a:defRPr sz="1950" b="0">
+                <a:solidFill>
+                  <a:srgbClr val="183153"/>
+                </a:solidFill>
+                <a:latin typeface="Arial"/>
+                <a:ea typeface="Arial"/>
+                <a:cs typeface="Arial"/>
+              </a:defRPr>
+            </a:pPr>
+            <a:r>
+              <a:rPr sz="1950" b="0">
+                <a:solidFill>
+                  <a:srgbClr val="183153"/>
+                </a:solidFill>
+                <a:latin typeface="Arial"/>
+                <a:ea typeface="Arial"/>
+                <a:cs typeface="Arial"/>
+              </a:rPr>
+              <a:t>or preserve the bucket-load histogram.</a:t>
             </a:r>
           </a:p>
         </p:txBody>

</xml_diff>